<commit_message>
Redirect User To Specific Page After Login
</commit_message>
<xml_diff>
--- a/.lessons/28 Fundamental Authentication/2 Redirect User To Specific Page After Login/1.pptx
+++ b/.lessons/28 Fundamental Authentication/2 Redirect User To Specific Page After Login/1.pptx
@@ -7,7 +7,11 @@
   <p:sldIdLst>
     <p:sldId id="402" r:id="rId2"/>
     <p:sldId id="403" r:id="rId3"/>
-    <p:sldId id="400" r:id="rId4"/>
+    <p:sldId id="404" r:id="rId4"/>
+    <p:sldId id="405" r:id="rId5"/>
+    <p:sldId id="406" r:id="rId6"/>
+    <p:sldId id="407" r:id="rId7"/>
+    <p:sldId id="400" r:id="rId8"/>
   </p:sldIdLst>
   <p:sldSz cx="12192000" cy="6858000"/>
   <p:notesSz cx="6858000" cy="9144000"/>
@@ -261,7 +265,7 @@
           <a:p>
             <a:fld id="{3E102D2E-813C-461C-9963-687A650C48C0}" type="datetimeFigureOut">
               <a:rPr lang="en-US" smtClean="0"/>
-              <a:t>5/23/2025</a:t>
+              <a:t>5/31/2025</a:t>
             </a:fld>
             <a:endParaRPr lang="en-US"/>
           </a:p>
@@ -459,7 +463,7 @@
           <a:p>
             <a:fld id="{3E102D2E-813C-461C-9963-687A650C48C0}" type="datetimeFigureOut">
               <a:rPr lang="en-US" smtClean="0"/>
-              <a:t>5/23/2025</a:t>
+              <a:t>5/31/2025</a:t>
             </a:fld>
             <a:endParaRPr lang="en-US"/>
           </a:p>
@@ -667,7 +671,7 @@
           <a:p>
             <a:fld id="{3E102D2E-813C-461C-9963-687A650C48C0}" type="datetimeFigureOut">
               <a:rPr lang="en-US" smtClean="0"/>
-              <a:t>5/23/2025</a:t>
+              <a:t>5/31/2025</a:t>
             </a:fld>
             <a:endParaRPr lang="en-US"/>
           </a:p>
@@ -865,7 +869,7 @@
           <a:p>
             <a:fld id="{3E102D2E-813C-461C-9963-687A650C48C0}" type="datetimeFigureOut">
               <a:rPr lang="en-US" smtClean="0"/>
-              <a:t>5/23/2025</a:t>
+              <a:t>5/31/2025</a:t>
             </a:fld>
             <a:endParaRPr lang="en-US"/>
           </a:p>
@@ -1140,7 +1144,7 @@
           <a:p>
             <a:fld id="{3E102D2E-813C-461C-9963-687A650C48C0}" type="datetimeFigureOut">
               <a:rPr lang="en-US" smtClean="0"/>
-              <a:t>5/23/2025</a:t>
+              <a:t>5/31/2025</a:t>
             </a:fld>
             <a:endParaRPr lang="en-US"/>
           </a:p>
@@ -1405,7 +1409,7 @@
           <a:p>
             <a:fld id="{3E102D2E-813C-461C-9963-687A650C48C0}" type="datetimeFigureOut">
               <a:rPr lang="en-US" smtClean="0"/>
-              <a:t>5/23/2025</a:t>
+              <a:t>5/31/2025</a:t>
             </a:fld>
             <a:endParaRPr lang="en-US"/>
           </a:p>
@@ -1817,7 +1821,7 @@
           <a:p>
             <a:fld id="{3E102D2E-813C-461C-9963-687A650C48C0}" type="datetimeFigureOut">
               <a:rPr lang="en-US" smtClean="0"/>
-              <a:t>5/23/2025</a:t>
+              <a:t>5/31/2025</a:t>
             </a:fld>
             <a:endParaRPr lang="en-US"/>
           </a:p>
@@ -1958,7 +1962,7 @@
           <a:p>
             <a:fld id="{3E102D2E-813C-461C-9963-687A650C48C0}" type="datetimeFigureOut">
               <a:rPr lang="en-US" smtClean="0"/>
-              <a:t>5/23/2025</a:t>
+              <a:t>5/31/2025</a:t>
             </a:fld>
             <a:endParaRPr lang="en-US"/>
           </a:p>
@@ -2071,7 +2075,7 @@
           <a:p>
             <a:fld id="{3E102D2E-813C-461C-9963-687A650C48C0}" type="datetimeFigureOut">
               <a:rPr lang="en-US" smtClean="0"/>
-              <a:t>5/23/2025</a:t>
+              <a:t>5/31/2025</a:t>
             </a:fld>
             <a:endParaRPr lang="en-US"/>
           </a:p>
@@ -2382,7 +2386,7 @@
           <a:p>
             <a:fld id="{3E102D2E-813C-461C-9963-687A650C48C0}" type="datetimeFigureOut">
               <a:rPr lang="en-US" smtClean="0"/>
-              <a:t>5/23/2025</a:t>
+              <a:t>5/31/2025</a:t>
             </a:fld>
             <a:endParaRPr lang="en-US"/>
           </a:p>
@@ -2670,7 +2674,7 @@
           <a:p>
             <a:fld id="{3E102D2E-813C-461C-9963-687A650C48C0}" type="datetimeFigureOut">
               <a:rPr lang="en-US" smtClean="0"/>
-              <a:t>5/23/2025</a:t>
+              <a:t>5/31/2025</a:t>
             </a:fld>
             <a:endParaRPr lang="en-US"/>
           </a:p>
@@ -2911,7 +2915,7 @@
           <a:p>
             <a:fld id="{3E102D2E-813C-461C-9963-687A650C48C0}" type="datetimeFigureOut">
               <a:rPr lang="en-US" smtClean="0"/>
-              <a:t>5/23/2025</a:t>
+              <a:t>5/31/2025</a:t>
             </a:fld>
             <a:endParaRPr lang="en-US"/>
           </a:p>
@@ -3349,7 +3353,7 @@
         <p:spPr>
           <a:xfrm>
             <a:off x="217714" y="255046"/>
-            <a:ext cx="11756571" cy="355354"/>
+            <a:ext cx="11756571" cy="955518"/>
           </a:xfrm>
           <a:prstGeom prst="rect">
             <a:avLst/>
@@ -3369,7 +3373,45 @@
               <a:buNone/>
             </a:pPr>
             <a:r>
-              <a:rPr kumimoji="0" lang="en-US" altLang="en-US" sz="1300" b="0" i="0" u="none" strike="noStrike" cap="none" normalizeH="0" baseline="0">
+              <a:rPr lang="az-Latn-AZ" altLang="en-US" sz="1300">
+                <a:latin typeface="Arial" panose="020B0604020202020204" pitchFamily="34" charset="0"/>
+              </a:rPr>
+              <a:t>Bu dərsə başlamadan əvvəl qısaca köhnə dərsə həm bir göz gəzdirək həmdə `</a:t>
+            </a:r>
+            <a:r>
+              <a:rPr lang="az-Latn-AZ" altLang="en-US" sz="1300" b="1">
+                <a:latin typeface="Arial" panose="020B0604020202020204" pitchFamily="34" charset="0"/>
+              </a:rPr>
+              <a:t>posts</a:t>
+            </a:r>
+            <a:r>
+              <a:rPr lang="az-Latn-AZ" altLang="en-US" sz="1300">
+                <a:latin typeface="Arial" panose="020B0604020202020204" pitchFamily="34" charset="0"/>
+              </a:rPr>
+              <a:t>` ilə əlaqəli route -ları </a:t>
+            </a:r>
+            <a:r>
+              <a:rPr lang="en-US" altLang="en-US" sz="1300" b="1">
+                <a:latin typeface="Arial" panose="020B0604020202020204" pitchFamily="34" charset="0"/>
+              </a:rPr>
+              <a:t>web.php </a:t>
+            </a:r>
+            <a:r>
+              <a:rPr lang="az-Latn-AZ" altLang="en-US" sz="1300">
+                <a:latin typeface="Arial" panose="020B0604020202020204" pitchFamily="34" charset="0"/>
+              </a:rPr>
+              <a:t>faylına əlavə edək.</a:t>
+            </a:r>
+          </a:p>
+          <a:p>
+            <a:pPr>
+              <a:lnSpc>
+                <a:spcPct val="150000"/>
+              </a:lnSpc>
+              <a:buNone/>
+            </a:pPr>
+            <a:r>
+              <a:rPr kumimoji="0" lang="az-Latn-AZ" altLang="en-US" sz="1300" b="0" i="0" u="none" strike="noStrike" cap="none" normalizeH="0" baseline="0">
                 <a:ln>
                   <a:noFill/>
                 </a:ln>
@@ -3379,11 +3421,114 @@
                 <a:effectLst/>
                 <a:latin typeface="Arial" panose="020B0604020202020204" pitchFamily="34" charset="0"/>
               </a:rPr>
-              <a:t>.</a:t>
-            </a:r>
-          </a:p>
-        </p:txBody>
-      </p:sp>
+              <a:t>Burada açılan </a:t>
+            </a:r>
+            <a:r>
+              <a:rPr lang="az-Latn-AZ" altLang="en-US" sz="1300">
+                <a:latin typeface="Arial" panose="020B0604020202020204" pitchFamily="34" charset="0"/>
+              </a:rPr>
+              <a:t>şablon sadəcə: `</a:t>
+            </a:r>
+            <a:r>
+              <a:rPr lang="az-Latn-AZ" altLang="en-US" sz="1300" u="sng">
+                <a:solidFill>
+                  <a:srgbClr val="0070C0"/>
+                </a:solidFill>
+                <a:latin typeface="Arial" panose="020B0604020202020204" pitchFamily="34" charset="0"/>
+              </a:rPr>
+              <a:t>http://vendor-e-commerce.test/posts</a:t>
+            </a:r>
+            <a:r>
+              <a:rPr lang="az-Latn-AZ" altLang="en-US" sz="1300">
+                <a:latin typeface="Arial" panose="020B0604020202020204" pitchFamily="34" charset="0"/>
+              </a:rPr>
+              <a:t>` -dur. Digərlərinin açılması üçün </a:t>
+            </a:r>
+            <a:r>
+              <a:rPr lang="az-Latn-AZ" altLang="en-US" sz="1300" b="1">
+                <a:latin typeface="Arial" panose="020B0604020202020204" pitchFamily="34" charset="0"/>
+              </a:rPr>
+              <a:t>URL</a:t>
+            </a:r>
+            <a:r>
+              <a:rPr lang="az-Latn-AZ" altLang="en-US" sz="1300">
+                <a:latin typeface="Arial" panose="020B0604020202020204" pitchFamily="34" charset="0"/>
+              </a:rPr>
+              <a:t> -də parametr kimi </a:t>
+            </a:r>
+            <a:r>
+              <a:rPr lang="az-Latn-AZ" altLang="en-US" sz="1300" b="1">
+                <a:latin typeface="Arial" panose="020B0604020202020204" pitchFamily="34" charset="0"/>
+              </a:rPr>
+              <a:t>AUTH</a:t>
+            </a:r>
+            <a:r>
+              <a:rPr lang="az-Latn-AZ" altLang="en-US" sz="1300">
+                <a:latin typeface="Arial" panose="020B0604020202020204" pitchFamily="34" charset="0"/>
+              </a:rPr>
+              <a:t> olmalıdır. Bunu </a:t>
+            </a:r>
+            <a:r>
+              <a:rPr lang="en-US" altLang="en-US" sz="1300" b="1">
+                <a:latin typeface="Arial" panose="020B0604020202020204" pitchFamily="34" charset="0"/>
+              </a:rPr>
+              <a:t>Middleware</a:t>
+            </a:r>
+            <a:r>
+              <a:rPr lang="en-US" altLang="en-US" sz="1300">
+                <a:latin typeface="Arial" panose="020B0604020202020204" pitchFamily="34" charset="0"/>
+              </a:rPr>
+              <a:t> </a:t>
+            </a:r>
+            <a:r>
+              <a:rPr lang="az-Latn-AZ" altLang="en-US" sz="1300">
+                <a:latin typeface="Arial" panose="020B0604020202020204" pitchFamily="34" charset="0"/>
+              </a:rPr>
+              <a:t>yazaraq özümüz təyin etmişik. İstəsəz silə bilərsiz. </a:t>
+            </a:r>
+            <a:endParaRPr kumimoji="0" lang="en-US" altLang="en-US" sz="1300" b="0" i="0" u="none" strike="noStrike" cap="none" normalizeH="0" baseline="0">
+              <a:ln>
+                <a:noFill/>
+              </a:ln>
+              <a:solidFill>
+                <a:schemeClr val="tx1"/>
+              </a:solidFill>
+              <a:effectLst/>
+              <a:latin typeface="Arial" panose="020B0604020202020204" pitchFamily="34" charset="0"/>
+            </a:endParaRPr>
+          </a:p>
+        </p:txBody>
+      </p:sp>
+      <p:pic>
+        <p:nvPicPr>
+          <p:cNvPr id="4" name="Picture 3">
+            <a:extLst>
+              <a:ext uri="{FF2B5EF4-FFF2-40B4-BE49-F238E27FC236}">
+                <a16:creationId xmlns:a16="http://schemas.microsoft.com/office/drawing/2014/main" id="{1A6BAC8E-B221-7553-0D93-D4F61D07D4A2}"/>
+              </a:ext>
+            </a:extLst>
+          </p:cNvPr>
+          <p:cNvPicPr>
+            <a:picLocks noChangeAspect="1"/>
+          </p:cNvPicPr>
+          <p:nvPr/>
+        </p:nvPicPr>
+        <p:blipFill>
+          <a:blip r:embed="rId2"/>
+          <a:stretch>
+            <a:fillRect/>
+          </a:stretch>
+        </p:blipFill>
+        <p:spPr>
+          <a:xfrm>
+            <a:off x="0" y="1394202"/>
+            <a:ext cx="12192000" cy="5463798"/>
+          </a:xfrm>
+          <a:prstGeom prst="rect">
+            <a:avLst/>
+          </a:prstGeom>
+        </p:spPr>
+      </p:pic>
     </p:spTree>
     <p:extLst>
       <p:ext uri="{BB962C8B-B14F-4D97-AF65-F5344CB8AC3E}">
@@ -3435,7 +3580,7 @@
         <p:spPr>
           <a:xfrm>
             <a:off x="217714" y="255046"/>
-            <a:ext cx="11756571" cy="355354"/>
+            <a:ext cx="11756571" cy="655436"/>
           </a:xfrm>
           <a:prstGeom prst="rect">
             <a:avLst/>
@@ -3455,21 +3600,108 @@
               <a:buNone/>
             </a:pPr>
             <a:r>
-              <a:rPr kumimoji="0" lang="en-US" altLang="en-US" sz="1300" b="0" i="0" u="none" strike="noStrike" cap="none" normalizeH="0" baseline="0">
-                <a:ln>
-                  <a:noFill/>
-                </a:ln>
-                <a:solidFill>
-                  <a:schemeClr val="tx1"/>
-                </a:solidFill>
-                <a:effectLst/>
+              <a:rPr lang="az-Latn-AZ" altLang="en-US" sz="1300">
                 <a:latin typeface="Arial" panose="020B0604020202020204" pitchFamily="34" charset="0"/>
               </a:rPr>
-              <a:t>.</a:t>
-            </a:r>
-          </a:p>
-        </p:txBody>
-      </p:sp>
+              <a:t>Saytda </a:t>
+            </a:r>
+            <a:r>
+              <a:rPr lang="az-Latn-AZ" altLang="en-US" sz="1300" b="1">
+                <a:latin typeface="Arial" panose="020B0604020202020204" pitchFamily="34" charset="0"/>
+              </a:rPr>
+              <a:t>LOGİN</a:t>
+            </a:r>
+            <a:r>
+              <a:rPr lang="az-Latn-AZ" altLang="en-US" sz="1300">
+                <a:latin typeface="Arial" panose="020B0604020202020204" pitchFamily="34" charset="0"/>
+              </a:rPr>
+              <a:t> olduqda proqram kodu bizi avtomatik </a:t>
+            </a:r>
+            <a:r>
+              <a:rPr lang="az-Latn-AZ" altLang="en-US" sz="1300" b="1">
+                <a:latin typeface="Arial" panose="020B0604020202020204" pitchFamily="34" charset="0"/>
+              </a:rPr>
+              <a:t>DASHBOARD</a:t>
+            </a:r>
+            <a:r>
+              <a:rPr lang="az-Latn-AZ" altLang="en-US" sz="1300">
+                <a:latin typeface="Arial" panose="020B0604020202020204" pitchFamily="34" charset="0"/>
+              </a:rPr>
+              <a:t> şablonuna göndərir. Bunu dəyişdirmək üçün yəni məsələn POSTS şablonuna yönləndirilmək üçün, `app\Providers\RouteServiceProvider.php` adlı faylda dəyişiklik etmək lazımdır. </a:t>
+            </a:r>
+            <a:endParaRPr kumimoji="0" lang="en-US" altLang="en-US" sz="1300" b="0" i="0" u="none" strike="noStrike" cap="none" normalizeH="0" baseline="0">
+              <a:ln>
+                <a:noFill/>
+              </a:ln>
+              <a:solidFill>
+                <a:schemeClr val="tx1"/>
+              </a:solidFill>
+              <a:effectLst/>
+              <a:latin typeface="Arial" panose="020B0604020202020204" pitchFamily="34" charset="0"/>
+            </a:endParaRPr>
+          </a:p>
+        </p:txBody>
+      </p:sp>
+      <p:pic>
+        <p:nvPicPr>
+          <p:cNvPr id="4" name="Picture 3">
+            <a:extLst>
+              <a:ext uri="{FF2B5EF4-FFF2-40B4-BE49-F238E27FC236}">
+                <a16:creationId xmlns:a16="http://schemas.microsoft.com/office/drawing/2014/main" id="{05F74186-CC3F-A279-9E40-1F76CAD41B0E}"/>
+              </a:ext>
+            </a:extLst>
+          </p:cNvPr>
+          <p:cNvPicPr>
+            <a:picLocks noChangeAspect="1"/>
+          </p:cNvPicPr>
+          <p:nvPr/>
+        </p:nvPicPr>
+        <p:blipFill>
+          <a:blip r:embed="rId2"/>
+          <a:stretch>
+            <a:fillRect/>
+          </a:stretch>
+        </p:blipFill>
+        <p:spPr>
+          <a:xfrm>
+            <a:off x="-1" y="3601167"/>
+            <a:ext cx="5867235" cy="3256833"/>
+          </a:xfrm>
+          <a:prstGeom prst="rect">
+            <a:avLst/>
+          </a:prstGeom>
+        </p:spPr>
+      </p:pic>
+      <p:pic>
+        <p:nvPicPr>
+          <p:cNvPr id="6" name="Picture 5">
+            <a:extLst>
+              <a:ext uri="{FF2B5EF4-FFF2-40B4-BE49-F238E27FC236}">
+                <a16:creationId xmlns:a16="http://schemas.microsoft.com/office/drawing/2014/main" id="{597FA6BF-23DE-F4D5-AE6E-E6025751350D}"/>
+              </a:ext>
+            </a:extLst>
+          </p:cNvPr>
+          <p:cNvPicPr>
+            <a:picLocks noChangeAspect="1"/>
+          </p:cNvPicPr>
+          <p:nvPr/>
+        </p:nvPicPr>
+        <p:blipFill>
+          <a:blip r:embed="rId3"/>
+          <a:stretch>
+            <a:fillRect/>
+          </a:stretch>
+        </p:blipFill>
+        <p:spPr>
+          <a:xfrm>
+            <a:off x="6130301" y="3601167"/>
+            <a:ext cx="6060762" cy="3256833"/>
+          </a:xfrm>
+          <a:prstGeom prst="rect">
+            <a:avLst/>
+          </a:prstGeom>
+        </p:spPr>
+      </p:pic>
     </p:spTree>
     <p:extLst>
       <p:ext uri="{BB962C8B-B14F-4D97-AF65-F5344CB8AC3E}">
@@ -3484,6 +3716,350 @@
 </file>
 
 <file path=ppt/slides/slide3.xml><?xml version="1.0" encoding="utf-8"?>
+<p:sld xmlns:a="http://schemas.openxmlformats.org/drawingml/2006/main" xmlns:r="http://schemas.openxmlformats.org/officeDocument/2006/relationships" xmlns:p="http://schemas.openxmlformats.org/presentationml/2006/main">
+  <p:cSld>
+    <p:spTree>
+      <p:nvGrpSpPr>
+        <p:cNvPr id="1" name="">
+          <a:extLst>
+            <a:ext uri="{FF2B5EF4-FFF2-40B4-BE49-F238E27FC236}">
+              <a16:creationId xmlns:a16="http://schemas.microsoft.com/office/drawing/2014/main" id="{E45F6C96-54F0-DDFE-762F-C996C07A0235}"/>
+            </a:ext>
+          </a:extLst>
+        </p:cNvPr>
+        <p:cNvGrpSpPr/>
+        <p:nvPr/>
+      </p:nvGrpSpPr>
+      <p:grpSpPr>
+        <a:xfrm>
+          <a:off x="0" y="0"/>
+          <a:ext cx="0" cy="0"/>
+          <a:chOff x="0" y="0"/>
+          <a:chExt cx="0" cy="0"/>
+        </a:xfrm>
+      </p:grpSpPr>
+      <p:sp>
+        <p:nvSpPr>
+          <p:cNvPr id="3" name="TextBox 2">
+            <a:extLst>
+              <a:ext uri="{FF2B5EF4-FFF2-40B4-BE49-F238E27FC236}">
+                <a16:creationId xmlns:a16="http://schemas.microsoft.com/office/drawing/2014/main" id="{404A6678-6E96-B08E-88E2-E0BD620F2B05}"/>
+              </a:ext>
+            </a:extLst>
+          </p:cNvPr>
+          <p:cNvSpPr txBox="1"/>
+          <p:nvPr/>
+        </p:nvSpPr>
+        <p:spPr>
+          <a:xfrm>
+            <a:off x="217714" y="255046"/>
+            <a:ext cx="11756571" cy="355354"/>
+          </a:xfrm>
+          <a:prstGeom prst="rect">
+            <a:avLst/>
+          </a:prstGeom>
+          <a:noFill/>
+        </p:spPr>
+        <p:txBody>
+          <a:bodyPr wrap="square">
+            <a:spAutoFit/>
+          </a:bodyPr>
+          <a:lstStyle/>
+          <a:p>
+            <a:pPr>
+              <a:lnSpc>
+                <a:spcPct val="150000"/>
+              </a:lnSpc>
+              <a:buNone/>
+            </a:pPr>
+            <a:r>
+              <a:rPr kumimoji="0" lang="en-US" altLang="en-US" sz="1300" b="0" i="0" u="none" strike="noStrike" cap="none" normalizeH="0" baseline="0">
+                <a:ln>
+                  <a:noFill/>
+                </a:ln>
+                <a:solidFill>
+                  <a:schemeClr val="tx1"/>
+                </a:solidFill>
+                <a:effectLst/>
+                <a:latin typeface="Arial" panose="020B0604020202020204" pitchFamily="34" charset="0"/>
+              </a:rPr>
+              <a:t>.</a:t>
+            </a:r>
+          </a:p>
+        </p:txBody>
+      </p:sp>
+    </p:spTree>
+    <p:extLst>
+      <p:ext uri="{BB962C8B-B14F-4D97-AF65-F5344CB8AC3E}">
+        <p14:creationId xmlns:p14="http://schemas.microsoft.com/office/powerpoint/2010/main" val="1671805141"/>
+      </p:ext>
+    </p:extLst>
+  </p:cSld>
+  <p:clrMapOvr>
+    <a:masterClrMapping/>
+  </p:clrMapOvr>
+</p:sld>
+</file>
+
+<file path=ppt/slides/slide4.xml><?xml version="1.0" encoding="utf-8"?>
+<p:sld xmlns:a="http://schemas.openxmlformats.org/drawingml/2006/main" xmlns:r="http://schemas.openxmlformats.org/officeDocument/2006/relationships" xmlns:p="http://schemas.openxmlformats.org/presentationml/2006/main">
+  <p:cSld>
+    <p:spTree>
+      <p:nvGrpSpPr>
+        <p:cNvPr id="1" name="">
+          <a:extLst>
+            <a:ext uri="{FF2B5EF4-FFF2-40B4-BE49-F238E27FC236}">
+              <a16:creationId xmlns:a16="http://schemas.microsoft.com/office/drawing/2014/main" id="{68408D7D-2B36-B466-85F7-ADC3C3BD7EB3}"/>
+            </a:ext>
+          </a:extLst>
+        </p:cNvPr>
+        <p:cNvGrpSpPr/>
+        <p:nvPr/>
+      </p:nvGrpSpPr>
+      <p:grpSpPr>
+        <a:xfrm>
+          <a:off x="0" y="0"/>
+          <a:ext cx="0" cy="0"/>
+          <a:chOff x="0" y="0"/>
+          <a:chExt cx="0" cy="0"/>
+        </a:xfrm>
+      </p:grpSpPr>
+      <p:sp>
+        <p:nvSpPr>
+          <p:cNvPr id="3" name="TextBox 2">
+            <a:extLst>
+              <a:ext uri="{FF2B5EF4-FFF2-40B4-BE49-F238E27FC236}">
+                <a16:creationId xmlns:a16="http://schemas.microsoft.com/office/drawing/2014/main" id="{73478EFE-DD78-B678-EE23-561A5CA8A07E}"/>
+              </a:ext>
+            </a:extLst>
+          </p:cNvPr>
+          <p:cNvSpPr txBox="1"/>
+          <p:nvPr/>
+        </p:nvSpPr>
+        <p:spPr>
+          <a:xfrm>
+            <a:off x="217714" y="255046"/>
+            <a:ext cx="11756571" cy="355354"/>
+          </a:xfrm>
+          <a:prstGeom prst="rect">
+            <a:avLst/>
+          </a:prstGeom>
+          <a:noFill/>
+        </p:spPr>
+        <p:txBody>
+          <a:bodyPr wrap="square">
+            <a:spAutoFit/>
+          </a:bodyPr>
+          <a:lstStyle/>
+          <a:p>
+            <a:pPr>
+              <a:lnSpc>
+                <a:spcPct val="150000"/>
+              </a:lnSpc>
+              <a:buNone/>
+            </a:pPr>
+            <a:r>
+              <a:rPr kumimoji="0" lang="en-US" altLang="en-US" sz="1300" b="0" i="0" u="none" strike="noStrike" cap="none" normalizeH="0" baseline="0">
+                <a:ln>
+                  <a:noFill/>
+                </a:ln>
+                <a:solidFill>
+                  <a:schemeClr val="tx1"/>
+                </a:solidFill>
+                <a:effectLst/>
+                <a:latin typeface="Arial" panose="020B0604020202020204" pitchFamily="34" charset="0"/>
+              </a:rPr>
+              <a:t>.</a:t>
+            </a:r>
+          </a:p>
+        </p:txBody>
+      </p:sp>
+    </p:spTree>
+    <p:extLst>
+      <p:ext uri="{BB962C8B-B14F-4D97-AF65-F5344CB8AC3E}">
+        <p14:creationId xmlns:p14="http://schemas.microsoft.com/office/powerpoint/2010/main" val="23097678"/>
+      </p:ext>
+    </p:extLst>
+  </p:cSld>
+  <p:clrMapOvr>
+    <a:masterClrMapping/>
+  </p:clrMapOvr>
+</p:sld>
+</file>
+
+<file path=ppt/slides/slide5.xml><?xml version="1.0" encoding="utf-8"?>
+<p:sld xmlns:a="http://schemas.openxmlformats.org/drawingml/2006/main" xmlns:r="http://schemas.openxmlformats.org/officeDocument/2006/relationships" xmlns:p="http://schemas.openxmlformats.org/presentationml/2006/main">
+  <p:cSld>
+    <p:spTree>
+      <p:nvGrpSpPr>
+        <p:cNvPr id="1" name="">
+          <a:extLst>
+            <a:ext uri="{FF2B5EF4-FFF2-40B4-BE49-F238E27FC236}">
+              <a16:creationId xmlns:a16="http://schemas.microsoft.com/office/drawing/2014/main" id="{DBF037A7-DC61-9A49-9BEF-B14E890BD587}"/>
+            </a:ext>
+          </a:extLst>
+        </p:cNvPr>
+        <p:cNvGrpSpPr/>
+        <p:nvPr/>
+      </p:nvGrpSpPr>
+      <p:grpSpPr>
+        <a:xfrm>
+          <a:off x="0" y="0"/>
+          <a:ext cx="0" cy="0"/>
+          <a:chOff x="0" y="0"/>
+          <a:chExt cx="0" cy="0"/>
+        </a:xfrm>
+      </p:grpSpPr>
+      <p:sp>
+        <p:nvSpPr>
+          <p:cNvPr id="3" name="TextBox 2">
+            <a:extLst>
+              <a:ext uri="{FF2B5EF4-FFF2-40B4-BE49-F238E27FC236}">
+                <a16:creationId xmlns:a16="http://schemas.microsoft.com/office/drawing/2014/main" id="{8C7AB19A-FC82-F9FC-808B-BEA603ECFFCC}"/>
+              </a:ext>
+            </a:extLst>
+          </p:cNvPr>
+          <p:cNvSpPr txBox="1"/>
+          <p:nvPr/>
+        </p:nvSpPr>
+        <p:spPr>
+          <a:xfrm>
+            <a:off x="217714" y="255046"/>
+            <a:ext cx="11756571" cy="355354"/>
+          </a:xfrm>
+          <a:prstGeom prst="rect">
+            <a:avLst/>
+          </a:prstGeom>
+          <a:noFill/>
+        </p:spPr>
+        <p:txBody>
+          <a:bodyPr wrap="square">
+            <a:spAutoFit/>
+          </a:bodyPr>
+          <a:lstStyle/>
+          <a:p>
+            <a:pPr>
+              <a:lnSpc>
+                <a:spcPct val="150000"/>
+              </a:lnSpc>
+              <a:buNone/>
+            </a:pPr>
+            <a:r>
+              <a:rPr kumimoji="0" lang="en-US" altLang="en-US" sz="1300" b="0" i="0" u="none" strike="noStrike" cap="none" normalizeH="0" baseline="0">
+                <a:ln>
+                  <a:noFill/>
+                </a:ln>
+                <a:solidFill>
+                  <a:schemeClr val="tx1"/>
+                </a:solidFill>
+                <a:effectLst/>
+                <a:latin typeface="Arial" panose="020B0604020202020204" pitchFamily="34" charset="0"/>
+              </a:rPr>
+              <a:t>.</a:t>
+            </a:r>
+          </a:p>
+        </p:txBody>
+      </p:sp>
+    </p:spTree>
+    <p:extLst>
+      <p:ext uri="{BB962C8B-B14F-4D97-AF65-F5344CB8AC3E}">
+        <p14:creationId xmlns:p14="http://schemas.microsoft.com/office/powerpoint/2010/main" val="2156910455"/>
+      </p:ext>
+    </p:extLst>
+  </p:cSld>
+  <p:clrMapOvr>
+    <a:masterClrMapping/>
+  </p:clrMapOvr>
+</p:sld>
+</file>
+
+<file path=ppt/slides/slide6.xml><?xml version="1.0" encoding="utf-8"?>
+<p:sld xmlns:a="http://schemas.openxmlformats.org/drawingml/2006/main" xmlns:r="http://schemas.openxmlformats.org/officeDocument/2006/relationships" xmlns:p="http://schemas.openxmlformats.org/presentationml/2006/main">
+  <p:cSld>
+    <p:spTree>
+      <p:nvGrpSpPr>
+        <p:cNvPr id="1" name="">
+          <a:extLst>
+            <a:ext uri="{FF2B5EF4-FFF2-40B4-BE49-F238E27FC236}">
+              <a16:creationId xmlns:a16="http://schemas.microsoft.com/office/drawing/2014/main" id="{BCF7DD64-52DD-BB0C-E611-CEF785BFCB56}"/>
+            </a:ext>
+          </a:extLst>
+        </p:cNvPr>
+        <p:cNvGrpSpPr/>
+        <p:nvPr/>
+      </p:nvGrpSpPr>
+      <p:grpSpPr>
+        <a:xfrm>
+          <a:off x="0" y="0"/>
+          <a:ext cx="0" cy="0"/>
+          <a:chOff x="0" y="0"/>
+          <a:chExt cx="0" cy="0"/>
+        </a:xfrm>
+      </p:grpSpPr>
+      <p:sp>
+        <p:nvSpPr>
+          <p:cNvPr id="3" name="TextBox 2">
+            <a:extLst>
+              <a:ext uri="{FF2B5EF4-FFF2-40B4-BE49-F238E27FC236}">
+                <a16:creationId xmlns:a16="http://schemas.microsoft.com/office/drawing/2014/main" id="{7D5692B3-9F89-9FFD-1B22-1A04034D7002}"/>
+              </a:ext>
+            </a:extLst>
+          </p:cNvPr>
+          <p:cNvSpPr txBox="1"/>
+          <p:nvPr/>
+        </p:nvSpPr>
+        <p:spPr>
+          <a:xfrm>
+            <a:off x="217714" y="255046"/>
+            <a:ext cx="11756571" cy="355354"/>
+          </a:xfrm>
+          <a:prstGeom prst="rect">
+            <a:avLst/>
+          </a:prstGeom>
+          <a:noFill/>
+        </p:spPr>
+        <p:txBody>
+          <a:bodyPr wrap="square">
+            <a:spAutoFit/>
+          </a:bodyPr>
+          <a:lstStyle/>
+          <a:p>
+            <a:pPr>
+              <a:lnSpc>
+                <a:spcPct val="150000"/>
+              </a:lnSpc>
+              <a:buNone/>
+            </a:pPr>
+            <a:r>
+              <a:rPr kumimoji="0" lang="en-US" altLang="en-US" sz="1300" b="0" i="0" u="none" strike="noStrike" cap="none" normalizeH="0" baseline="0">
+                <a:ln>
+                  <a:noFill/>
+                </a:ln>
+                <a:solidFill>
+                  <a:schemeClr val="tx1"/>
+                </a:solidFill>
+                <a:effectLst/>
+                <a:latin typeface="Arial" panose="020B0604020202020204" pitchFamily="34" charset="0"/>
+              </a:rPr>
+              <a:t>.</a:t>
+            </a:r>
+          </a:p>
+        </p:txBody>
+      </p:sp>
+    </p:spTree>
+    <p:extLst>
+      <p:ext uri="{BB962C8B-B14F-4D97-AF65-F5344CB8AC3E}">
+        <p14:creationId xmlns:p14="http://schemas.microsoft.com/office/powerpoint/2010/main" val="3840566123"/>
+      </p:ext>
+    </p:extLst>
+  </p:cSld>
+  <p:clrMapOvr>
+    <a:masterClrMapping/>
+  </p:clrMapOvr>
+</p:sld>
+</file>
+
+<file path=ppt/slides/slide7.xml><?xml version="1.0" encoding="utf-8"?>
 <p:sld xmlns:a="http://schemas.openxmlformats.org/drawingml/2006/main" xmlns:r="http://schemas.openxmlformats.org/officeDocument/2006/relationships" xmlns:p="http://schemas.openxmlformats.org/presentationml/2006/main">
   <p:cSld>
     <p:spTree>

</xml_diff>